<commit_message>
Deliver final environmental slide with explicit pending cold vent stack decision
</commit_message>
<xml_diff>
--- a/informes/2026-10/entregables/SMP_HSE_Octubre_2026_v05_REVISADA.pptx
+++ b/informes/2026-10/entregables/SMP_HSE_Octubre_2026_v05_REVISADA.pptx
@@ -4625,6 +4625,12 @@
             </a:r>
           </a:p>
           <a:p/>
+          <a:p/>
+          <a:p>
+            <a:r>
+              <a:t>REDACCIÓN FINAL DE LA LÁMINA: se hace visible el término cold vent stack (Stack Frío) y su estado pendiente. Se explicita que la respuesta y presentación del Estudio de Riesgo Hídrico siguen pendientes, con Serman, para avanzar en el permiso. La aprobación de la adenda no equivale a resolver el Stack Frío. Los textos coinciden con los dos puntos que el usuario transcribió de los correos. No se añaden fotos ni nuevos hechos.</a:t>
+            </a:r>
+          </a:p>
         </p:txBody>
       </p:sp>
       <p:sp>
@@ -11440,7 +11446,7 @@
                 </a:solidFill>
                 <a:latin typeface="DejaVu Sans"/>
               </a:rPr>
-              <a:t>1.3 &gt; DEDICATED GAS PIPELINE UPDATE &gt; Environmental Performance Indicators</a:t>
+              <a:t>1.1 &gt; DEDICATED GAS PIPELINE UPDATE &gt; Safety | October Highlights</a:t>
             </a:r>
           </a:p>
         </p:txBody>
@@ -11522,47 +11528,8 @@
         </p:nvSpPr>
         <p:spPr>
           <a:xfrm>
-            <a:off x="438912" y="832104"/>
-            <a:ext cx="8321040" cy="237744"/>
-          </a:xfrm>
-          <a:prstGeom prst="rect">
-            <a:avLst/>
-          </a:prstGeom>
-          <a:noFill/>
-        </p:spPr>
-        <p:txBody>
-          <a:bodyPr wrap="square" lIns="18288" tIns="0" rIns="18288" bIns="0">
-            <a:spAutoFit/>
-          </a:bodyPr>
-          <a:lstStyle/>
-          <a:p>
-            <a:pPr>
-              <a:spcAft>
-                <a:spcPts val="500"/>
-              </a:spcAft>
-              <a:defRPr sz="900" b="0">
-                <a:solidFill>
-                  <a:srgbClr val="68717D"/>
-                </a:solidFill>
-                <a:latin typeface="DejaVu Sans"/>
-              </a:defRPr>
-            </a:pPr>
-            <a:r>
-              <a:t>Statistics through 30 September 2026 · values unchanged</a:t>
-            </a:r>
-          </a:p>
-        </p:txBody>
-      </p:sp>
-      <p:sp>
-        <p:nvSpPr>
-          <p:cNvPr id="14" name="TextBox 13"/>
-          <p:cNvSpPr txBox="1"/>
-          <p:nvPr/>
-        </p:nvSpPr>
-        <p:spPr>
-          <a:xfrm>
-            <a:off x="484632" y="1207008"/>
-            <a:ext cx="4023360" cy="274320"/>
+            <a:off x="411480" y="850392"/>
+            <a:ext cx="8321040" cy="320040"/>
           </a:xfrm>
           <a:prstGeom prst="rect">
             <a:avLst/>
@@ -11587,39 +11554,303 @@
               </a:defRPr>
             </a:pPr>
             <a:r>
-              <a:t>TOTAL WASTE GENERATION (kg/month)</a:t>
-            </a:r>
-          </a:p>
-        </p:txBody>
-      </p:sp>
-      <p:graphicFrame>
-        <p:nvGraphicFramePr>
-          <p:cNvPr id="15" name="Chart 14"/>
-          <p:cNvGraphicFramePr>
-            <a:graphicFrameLocks noGrp="1"/>
-          </p:cNvGraphicFramePr>
-          <p:nvPr/>
-        </p:nvGraphicFramePr>
-        <p:xfrm>
-          <a:off x="457200" y="1572768"/>
-          <a:ext cx="3063240" cy="2121408"/>
-        </p:xfrm>
-        <a:graphic>
-          <a:graphicData uri="http://schemas.openxmlformats.org/drawingml/2006/chart">
-            <c:chart xmlns:c="http://schemas.openxmlformats.org/drawingml/2006/chart" xmlns:r="http://schemas.openxmlformats.org/officeDocument/2006/relationships" r:id="rId4"/>
-          </a:graphicData>
-        </a:graphic>
-      </p:graphicFrame>
-      <p:sp>
-        <p:nvSpPr>
-          <p:cNvPr id="16" name="Rectangle 15"/>
+              <a:t>OCTOBER 2026 · PHOTOS &amp; RELEVANT HIGHLIGHTS · cut-off 27 Oct</a:t>
+            </a:r>
+          </a:p>
+        </p:txBody>
+      </p:sp>
+      <p:sp>
+        <p:nvSpPr>
+          <p:cNvPr id="14" name="Rectangle 13"/>
           <p:cNvSpPr/>
           <p:nvPr/>
         </p:nvSpPr>
         <p:spPr>
           <a:xfrm>
-            <a:off x="4114800" y="1901952"/>
-            <a:ext cx="2240280" cy="1024128"/>
+            <a:off x="411480" y="1417320"/>
+            <a:ext cx="4023360" cy="2331720"/>
+          </a:xfrm>
+          <a:prstGeom prst="rect">
+            <a:avLst/>
+          </a:prstGeom>
+          <a:solidFill>
+            <a:srgbClr val="F2F3F5"/>
+          </a:solidFill>
+          <a:ln>
+            <a:solidFill>
+              <a:srgbClr val="CDD2D9"/>
+            </a:solidFill>
+          </a:ln>
+          <a:effectLst/>
+        </p:spPr>
+        <p:style>
+          <a:lnRef idx="1">
+            <a:schemeClr val="accent1"/>
+          </a:lnRef>
+          <a:fillRef idx="3">
+            <a:schemeClr val="accent1"/>
+          </a:fillRef>
+          <a:effectRef idx="2">
+            <a:schemeClr val="accent1"/>
+          </a:effectRef>
+          <a:fontRef idx="minor">
+            <a:schemeClr val="lt1"/>
+          </a:fontRef>
+        </p:style>
+        <p:txBody>
+          <a:bodyPr rtlCol="0" anchor="ctr"/>
+          <a:lstStyle/>
+          <a:p>
+            <a:pPr algn="ctr"/>
+            <a:endParaRPr/>
+          </a:p>
+        </p:txBody>
+      </p:sp>
+      <p:sp>
+        <p:nvSpPr>
+          <p:cNvPr id="15" name="TextBox 14"/>
+          <p:cNvSpPr txBox="1"/>
+          <p:nvPr/>
+        </p:nvSpPr>
+        <p:spPr>
+          <a:xfrm>
+            <a:off x="548640" y="2148840"/>
+            <a:ext cx="3749039" cy="640080"/>
+          </a:xfrm>
+          <a:prstGeom prst="rect">
+            <a:avLst/>
+          </a:prstGeom>
+          <a:noFill/>
+        </p:spPr>
+        <p:txBody>
+          <a:bodyPr wrap="square" lIns="18288" tIns="0" rIns="18288" bIns="0">
+            <a:spAutoFit/>
+          </a:bodyPr>
+          <a:lstStyle/>
+          <a:p>
+            <a:pPr algn="ctr">
+              <a:spcAft>
+                <a:spcPts val="500"/>
+              </a:spcAft>
+              <a:defRPr sz="1500" b="0">
+                <a:solidFill>
+                  <a:srgbClr val="68717D"/>
+                </a:solidFill>
+                <a:latin typeface="DejaVu Sans"/>
+              </a:defRPr>
+            </a:pPr>
+            <a:r>
+              <a:t>OCTOBER PHOTO 1</a:t>
+            </a:r>
+          </a:p>
+          <a:p>
+            <a:pPr algn="ctr">
+              <a:spcAft>
+                <a:spcPts val="500"/>
+              </a:spcAft>
+              <a:defRPr sz="1500" b="0">
+                <a:solidFill>
+                  <a:srgbClr val="68717D"/>
+                </a:solidFill>
+                <a:latin typeface="DejaVu Sans"/>
+              </a:defRPr>
+            </a:pPr>
+            <a:r>
+              <a:t>Pending actual photo</a:t>
+            </a:r>
+          </a:p>
+        </p:txBody>
+      </p:sp>
+      <p:sp>
+        <p:nvSpPr>
+          <p:cNvPr id="16" name="TextBox 15"/>
+          <p:cNvSpPr txBox="1"/>
+          <p:nvPr/>
+        </p:nvSpPr>
+        <p:spPr>
+          <a:xfrm>
+            <a:off x="411480" y="3867912"/>
+            <a:ext cx="4023360" cy="502920"/>
+          </a:xfrm>
+          <a:prstGeom prst="rect">
+            <a:avLst/>
+          </a:prstGeom>
+          <a:noFill/>
+        </p:spPr>
+        <p:txBody>
+          <a:bodyPr wrap="square" lIns="18288" tIns="0" rIns="18288" bIns="0">
+            <a:spAutoFit/>
+          </a:bodyPr>
+          <a:lstStyle/>
+          <a:p>
+            <a:pPr>
+              <a:spcAft>
+                <a:spcPts val="500"/>
+              </a:spcAft>
+              <a:defRPr sz="950" b="0">
+                <a:solidFill>
+                  <a:srgbClr val="68717D"/>
+                </a:solidFill>
+                <a:latin typeface="DejaVu Sans"/>
+              </a:defRPr>
+            </a:pPr>
+            <a:r>
+              <a:t>Date / location / activity: pending confirmation</a:t>
+            </a:r>
+          </a:p>
+        </p:txBody>
+      </p:sp>
+      <p:sp>
+        <p:nvSpPr>
+          <p:cNvPr id="17" name="Rectangle 16"/>
+          <p:cNvSpPr/>
+          <p:nvPr/>
+        </p:nvSpPr>
+        <p:spPr>
+          <a:xfrm>
+            <a:off x="4681728" y="1417320"/>
+            <a:ext cx="4023360" cy="2331720"/>
+          </a:xfrm>
+          <a:prstGeom prst="rect">
+            <a:avLst/>
+          </a:prstGeom>
+          <a:solidFill>
+            <a:srgbClr val="F2F3F5"/>
+          </a:solidFill>
+          <a:ln>
+            <a:solidFill>
+              <a:srgbClr val="CDD2D9"/>
+            </a:solidFill>
+          </a:ln>
+          <a:effectLst/>
+        </p:spPr>
+        <p:style>
+          <a:lnRef idx="1">
+            <a:schemeClr val="accent1"/>
+          </a:lnRef>
+          <a:fillRef idx="3">
+            <a:schemeClr val="accent1"/>
+          </a:fillRef>
+          <a:effectRef idx="2">
+            <a:schemeClr val="accent1"/>
+          </a:effectRef>
+          <a:fontRef idx="minor">
+            <a:schemeClr val="lt1"/>
+          </a:fontRef>
+        </p:style>
+        <p:txBody>
+          <a:bodyPr rtlCol="0" anchor="ctr"/>
+          <a:lstStyle/>
+          <a:p>
+            <a:pPr algn="ctr"/>
+            <a:endParaRPr/>
+          </a:p>
+        </p:txBody>
+      </p:sp>
+      <p:sp>
+        <p:nvSpPr>
+          <p:cNvPr id="18" name="TextBox 17"/>
+          <p:cNvSpPr txBox="1"/>
+          <p:nvPr/>
+        </p:nvSpPr>
+        <p:spPr>
+          <a:xfrm>
+            <a:off x="4818888" y="2148840"/>
+            <a:ext cx="3749039" cy="640080"/>
+          </a:xfrm>
+          <a:prstGeom prst="rect">
+            <a:avLst/>
+          </a:prstGeom>
+          <a:noFill/>
+        </p:spPr>
+        <p:txBody>
+          <a:bodyPr wrap="square" lIns="18288" tIns="0" rIns="18288" bIns="0">
+            <a:spAutoFit/>
+          </a:bodyPr>
+          <a:lstStyle/>
+          <a:p>
+            <a:pPr algn="ctr">
+              <a:spcAft>
+                <a:spcPts val="500"/>
+              </a:spcAft>
+              <a:defRPr sz="1500" b="0">
+                <a:solidFill>
+                  <a:srgbClr val="68717D"/>
+                </a:solidFill>
+                <a:latin typeface="DejaVu Sans"/>
+              </a:defRPr>
+            </a:pPr>
+            <a:r>
+              <a:t>OCTOBER PHOTO 2</a:t>
+            </a:r>
+          </a:p>
+          <a:p>
+            <a:pPr algn="ctr">
+              <a:spcAft>
+                <a:spcPts val="500"/>
+              </a:spcAft>
+              <a:defRPr sz="1500" b="0">
+                <a:solidFill>
+                  <a:srgbClr val="68717D"/>
+                </a:solidFill>
+                <a:latin typeface="DejaVu Sans"/>
+              </a:defRPr>
+            </a:pPr>
+            <a:r>
+              <a:t>Pending actual photo</a:t>
+            </a:r>
+          </a:p>
+        </p:txBody>
+      </p:sp>
+      <p:sp>
+        <p:nvSpPr>
+          <p:cNvPr id="19" name="TextBox 18"/>
+          <p:cNvSpPr txBox="1"/>
+          <p:nvPr/>
+        </p:nvSpPr>
+        <p:spPr>
+          <a:xfrm>
+            <a:off x="4681728" y="3867912"/>
+            <a:ext cx="4023360" cy="502920"/>
+          </a:xfrm>
+          <a:prstGeom prst="rect">
+            <a:avLst/>
+          </a:prstGeom>
+          <a:noFill/>
+        </p:spPr>
+        <p:txBody>
+          <a:bodyPr wrap="square" lIns="18288" tIns="0" rIns="18288" bIns="0">
+            <a:spAutoFit/>
+          </a:bodyPr>
+          <a:lstStyle/>
+          <a:p>
+            <a:pPr>
+              <a:spcAft>
+                <a:spcPts val="500"/>
+              </a:spcAft>
+              <a:defRPr sz="950" b="0">
+                <a:solidFill>
+                  <a:srgbClr val="68717D"/>
+                </a:solidFill>
+                <a:latin typeface="DejaVu Sans"/>
+              </a:defRPr>
+            </a:pPr>
+            <a:r>
+              <a:t>Date / location / activity: pending confirmation</a:t>
+            </a:r>
+          </a:p>
+        </p:txBody>
+      </p:sp>
+      <p:sp>
+        <p:nvSpPr>
+          <p:cNvPr id="20" name="Rectangle 19"/>
+          <p:cNvSpPr/>
+          <p:nvPr/>
+        </p:nvSpPr>
+        <p:spPr>
+          <a:xfrm>
+            <a:off x="411480" y="4590288"/>
+            <a:ext cx="8293608" cy="1554480"/>
           </a:xfrm>
           <a:prstGeom prst="rect">
             <a:avLst/>
@@ -11657,59 +11888,14 @@
       </p:sp>
       <p:sp>
         <p:nvSpPr>
-          <p:cNvPr id="17" name="Rectangle 16"/>
-          <p:cNvSpPr/>
+          <p:cNvPr id="21" name="TextBox 20"/>
+          <p:cNvSpPr txBox="1"/>
           <p:nvPr/>
         </p:nvSpPr>
         <p:spPr>
           <a:xfrm>
-            <a:off x="4114800" y="1901952"/>
-            <a:ext cx="50292" cy="1024128"/>
-          </a:xfrm>
-          <a:prstGeom prst="rect">
-            <a:avLst/>
-          </a:prstGeom>
-          <a:solidFill>
-            <a:srgbClr val="013EF5"/>
-          </a:solidFill>
-          <a:ln>
-            <a:noFill/>
-          </a:ln>
-          <a:effectLst/>
-        </p:spPr>
-        <p:style>
-          <a:lnRef idx="1">
-            <a:schemeClr val="accent1"/>
-          </a:lnRef>
-          <a:fillRef idx="3">
-            <a:schemeClr val="accent1"/>
-          </a:fillRef>
-          <a:effectRef idx="2">
-            <a:schemeClr val="accent1"/>
-          </a:effectRef>
-          <a:fontRef idx="minor">
-            <a:schemeClr val="lt1"/>
-          </a:fontRef>
-        </p:style>
-        <p:txBody>
-          <a:bodyPr rtlCol="0" anchor="ctr"/>
-          <a:lstStyle/>
-          <a:p>
-            <a:pPr algn="ctr"/>
-            <a:endParaRPr/>
-          </a:p>
-        </p:txBody>
-      </p:sp>
-      <p:sp>
-        <p:nvSpPr>
-          <p:cNvPr id="18" name="TextBox 17"/>
-          <p:cNvSpPr txBox="1"/>
-          <p:nvPr/>
-        </p:nvSpPr>
-        <p:spPr>
-          <a:xfrm>
-            <a:off x="4224528" y="1984248"/>
-            <a:ext cx="2057400" cy="320040"/>
+            <a:off x="566928" y="4727448"/>
+            <a:ext cx="8001000" cy="274320"/>
           </a:xfrm>
           <a:prstGeom prst="rect">
             <a:avLst/>
@@ -11726,29 +11912,29 @@
               <a:spcAft>
                 <a:spcPts val="500"/>
               </a:spcAft>
-              <a:defRPr sz="850" b="1">
+              <a:defRPr sz="1200" b="1">
                 <a:solidFill>
-                  <a:srgbClr val="68717D"/>
+                  <a:srgbClr val="013EF5"/>
                 </a:solidFill>
                 <a:latin typeface="DejaVu Sans"/>
               </a:defRPr>
             </a:pPr>
             <a:r>
-              <a:t>% Waste recovery</a:t>
-            </a:r>
-          </a:p>
-        </p:txBody>
-      </p:sp>
-      <p:sp>
-        <p:nvSpPr>
-          <p:cNvPr id="19" name="TextBox 18"/>
+              <a:t>SAFETY — RELEVANT OCTOBER TOPICS</a:t>
+            </a:r>
+          </a:p>
+        </p:txBody>
+      </p:sp>
+      <p:sp>
+        <p:nvSpPr>
+          <p:cNvPr id="22" name="TextBox 21"/>
           <p:cNvSpPr txBox="1"/>
           <p:nvPr/>
         </p:nvSpPr>
         <p:spPr>
           <a:xfrm>
-            <a:off x="4224528" y="2359152"/>
-            <a:ext cx="2011680" cy="475488"/>
+            <a:off x="566928" y="5184648"/>
+            <a:ext cx="7863840" cy="749808"/>
           </a:xfrm>
           <a:prstGeom prst="rect">
             <a:avLst/>
@@ -11765,144 +11951,31 @@
               <a:spcAft>
                 <a:spcPts val="500"/>
               </a:spcAft>
-              <a:defRPr sz="2800" b="1">
+              <a:defRPr sz="1200" b="0">
                 <a:solidFill>
-                  <a:srgbClr val="013EF5"/>
+                  <a:srgbClr val="27364A"/>
                 </a:solidFill>
                 <a:latin typeface="DejaVu Sans"/>
               </a:defRPr>
             </a:pPr>
             <a:r>
-              <a:t>0%</a:t>
-            </a:r>
-          </a:p>
-        </p:txBody>
-      </p:sp>
-      <p:sp>
-        <p:nvSpPr>
-          <p:cNvPr id="20" name="Rectangle 19"/>
-          <p:cNvSpPr/>
-          <p:nvPr/>
-        </p:nvSpPr>
-        <p:spPr>
-          <a:xfrm>
-            <a:off x="6446520" y="1901952"/>
-            <a:ext cx="2240280" cy="1024128"/>
-          </a:xfrm>
-          <a:prstGeom prst="rect">
-            <a:avLst/>
-          </a:prstGeom>
-          <a:solidFill>
-            <a:srgbClr val="F2F3F5"/>
-          </a:solidFill>
-          <a:ln>
-            <a:noFill/>
-          </a:ln>
-          <a:effectLst/>
-        </p:spPr>
-        <p:style>
-          <a:lnRef idx="1">
-            <a:schemeClr val="accent1"/>
-          </a:lnRef>
-          <a:fillRef idx="3">
-            <a:schemeClr val="accent1"/>
-          </a:fillRef>
-          <a:effectRef idx="2">
-            <a:schemeClr val="accent1"/>
-          </a:effectRef>
-          <a:fontRef idx="minor">
-            <a:schemeClr val="lt1"/>
-          </a:fontRef>
-        </p:style>
-        <p:txBody>
-          <a:bodyPr rtlCol="0" anchor="ctr"/>
-          <a:lstStyle/>
-          <a:p>
-            <a:pPr algn="ctr"/>
-            <a:endParaRPr/>
-          </a:p>
-        </p:txBody>
-      </p:sp>
-      <p:sp>
-        <p:nvSpPr>
-          <p:cNvPr id="21" name="Rectangle 20"/>
-          <p:cNvSpPr/>
-          <p:nvPr/>
-        </p:nvSpPr>
-        <p:spPr>
-          <a:xfrm>
-            <a:off x="6446520" y="1901952"/>
-            <a:ext cx="50292" cy="1024128"/>
-          </a:xfrm>
-          <a:prstGeom prst="rect">
-            <a:avLst/>
-          </a:prstGeom>
-          <a:solidFill>
-            <a:srgbClr val="013EF5"/>
-          </a:solidFill>
-          <a:ln>
-            <a:noFill/>
-          </a:ln>
-          <a:effectLst/>
-        </p:spPr>
-        <p:style>
-          <a:lnRef idx="1">
-            <a:schemeClr val="accent1"/>
-          </a:lnRef>
-          <a:fillRef idx="3">
-            <a:schemeClr val="accent1"/>
-          </a:fillRef>
-          <a:effectRef idx="2">
-            <a:schemeClr val="accent1"/>
-          </a:effectRef>
-          <a:fontRef idx="minor">
-            <a:schemeClr val="lt1"/>
-          </a:fontRef>
-        </p:style>
-        <p:txBody>
-          <a:bodyPr rtlCol="0" anchor="ctr"/>
-          <a:lstStyle/>
-          <a:p>
-            <a:pPr algn="ctr"/>
-            <a:endParaRPr/>
-          </a:p>
-        </p:txBody>
-      </p:sp>
-      <p:sp>
-        <p:nvSpPr>
-          <p:cNvPr id="22" name="TextBox 21"/>
-          <p:cNvSpPr txBox="1"/>
-          <p:nvPr/>
-        </p:nvSpPr>
-        <p:spPr>
-          <a:xfrm>
-            <a:off x="6556248" y="1984248"/>
-            <a:ext cx="2057400" cy="320040"/>
-          </a:xfrm>
-          <a:prstGeom prst="rect">
-            <a:avLst/>
-          </a:prstGeom>
-          <a:noFill/>
-        </p:spPr>
-        <p:txBody>
-          <a:bodyPr wrap="square" lIns="18288" tIns="0" rIns="18288" bIns="0">
-            <a:spAutoFit/>
-          </a:bodyPr>
-          <a:lstStyle/>
+              <a:t>[Pending topics from Leandro Doglio]</a:t>
+            </a:r>
+          </a:p>
           <a:p>
             <a:pPr>
               <a:spcAft>
                 <a:spcPts val="500"/>
               </a:spcAft>
-              <a:defRPr sz="850" b="1">
+              <a:defRPr sz="1200" b="0">
                 <a:solidFill>
-                  <a:srgbClr val="68717D"/>
+                  <a:srgbClr val="27364A"/>
                 </a:solidFill>
                 <a:latin typeface="DejaVu Sans"/>
               </a:defRPr>
             </a:pPr>
             <a:r>
-              <a:t>% Waste final disposal / incinerated</a:t>
+              <a:t>Confirmed development · relevance · next step</a:t>
             </a:r>
           </a:p>
         </p:txBody>
@@ -11910,102 +11983,6 @@
       <p:sp>
         <p:nvSpPr>
           <p:cNvPr id="23" name="TextBox 22"/>
-          <p:cNvSpPr txBox="1"/>
-          <p:nvPr/>
-        </p:nvSpPr>
-        <p:spPr>
-          <a:xfrm>
-            <a:off x="6556248" y="2359152"/>
-            <a:ext cx="2011680" cy="475488"/>
-          </a:xfrm>
-          <a:prstGeom prst="rect">
-            <a:avLst/>
-          </a:prstGeom>
-          <a:noFill/>
-        </p:spPr>
-        <p:txBody>
-          <a:bodyPr wrap="square" lIns="18288" tIns="0" rIns="18288" bIns="0">
-            <a:spAutoFit/>
-          </a:bodyPr>
-          <a:lstStyle/>
-          <a:p>
-            <a:pPr>
-              <a:spcAft>
-                <a:spcPts val="500"/>
-              </a:spcAft>
-              <a:defRPr sz="2800" b="1">
-                <a:solidFill>
-                  <a:srgbClr val="013EF5"/>
-                </a:solidFill>
-                <a:latin typeface="DejaVu Sans"/>
-              </a:defRPr>
-            </a:pPr>
-            <a:r>
-              <a:t>100%</a:t>
-            </a:r>
-          </a:p>
-        </p:txBody>
-      </p:sp>
-      <p:sp>
-        <p:nvSpPr>
-          <p:cNvPr id="24" name="TextBox 23"/>
-          <p:cNvSpPr txBox="1"/>
-          <p:nvPr/>
-        </p:nvSpPr>
-        <p:spPr>
-          <a:xfrm>
-            <a:off x="484632" y="4023360"/>
-            <a:ext cx="4846320" cy="274320"/>
-          </a:xfrm>
-          <a:prstGeom prst="rect">
-            <a:avLst/>
-          </a:prstGeom>
-          <a:noFill/>
-        </p:spPr>
-        <p:txBody>
-          <a:bodyPr wrap="square" lIns="18288" tIns="0" rIns="18288" bIns="0">
-            <a:spAutoFit/>
-          </a:bodyPr>
-          <a:lstStyle/>
-          <a:p>
-            <a:pPr>
-              <a:spcAft>
-                <a:spcPts val="500"/>
-              </a:spcAft>
-              <a:defRPr sz="1100" b="1">
-                <a:solidFill>
-                  <a:srgbClr val="013EF5"/>
-                </a:solidFill>
-                <a:latin typeface="DejaVu Sans"/>
-              </a:defRPr>
-            </a:pPr>
-            <a:r>
-              <a:t>FRESHWATER CONSUMPTION (m³/month)</a:t>
-            </a:r>
-          </a:p>
-        </p:txBody>
-      </p:sp>
-      <p:graphicFrame>
-        <p:nvGraphicFramePr>
-          <p:cNvPr id="25" name="Chart 24"/>
-          <p:cNvGraphicFramePr>
-            <a:graphicFrameLocks noGrp="1"/>
-          </p:cNvGraphicFramePr>
-          <p:nvPr/>
-        </p:nvGraphicFramePr>
-        <p:xfrm>
-          <a:off x="457200" y="4370832"/>
-          <a:ext cx="3063240" cy="1947672"/>
-        </p:xfrm>
-        <a:graphic>
-          <a:graphicData uri="http://schemas.openxmlformats.org/drawingml/2006/chart">
-            <c:chart xmlns:c="http://schemas.openxmlformats.org/drawingml/2006/chart" xmlns:r="http://schemas.openxmlformats.org/officeDocument/2006/relationships" r:id="rId5"/>
-          </a:graphicData>
-        </a:graphic>
-      </p:graphicFrame>
-      <p:sp>
-        <p:nvSpPr>
-          <p:cNvPr id="26" name="TextBox 25"/>
           <p:cNvSpPr txBox="1"/>
           <p:nvPr/>
         </p:nvSpPr>
@@ -12044,7 +12021,7 @@
       </p:sp>
       <p:sp>
         <p:nvSpPr>
-          <p:cNvPr id="27" name="TextBox 26"/>
+          <p:cNvPr id="24" name="TextBox 23"/>
           <p:cNvSpPr txBox="1"/>
           <p:nvPr/>
         </p:nvSpPr>
@@ -12076,7 +12053,7 @@
               </a:defRPr>
             </a:pPr>
             <a:r>
-              <a:t>6</a:t>
+              <a:t>5</a:t>
             </a:r>
           </a:p>
         </p:txBody>
@@ -12212,7 +12189,7 @@
                 </a:solidFill>
                 <a:latin typeface="DejaVu Sans"/>
               </a:rPr>
-              <a:t>1.1 &gt; DEDICATED GAS PIPELINE UPDATE &gt; Safety | October Highlights</a:t>
+              <a:t>1.3 &gt; DEDICATED GAS PIPELINE UPDATE &gt; Environmental Performance Indicators</a:t>
             </a:r>
           </a:p>
         </p:txBody>
@@ -12294,8 +12271,47 @@
         </p:nvSpPr>
         <p:spPr>
           <a:xfrm>
-            <a:off x="411480" y="850392"/>
-            <a:ext cx="8321040" cy="320040"/>
+            <a:off x="438912" y="832104"/>
+            <a:ext cx="8321040" cy="237744"/>
+          </a:xfrm>
+          <a:prstGeom prst="rect">
+            <a:avLst/>
+          </a:prstGeom>
+          <a:noFill/>
+        </p:spPr>
+        <p:txBody>
+          <a:bodyPr wrap="square" lIns="18288" tIns="0" rIns="18288" bIns="0">
+            <a:spAutoFit/>
+          </a:bodyPr>
+          <a:lstStyle/>
+          <a:p>
+            <a:pPr>
+              <a:spcAft>
+                <a:spcPts val="500"/>
+              </a:spcAft>
+              <a:defRPr sz="900" b="0">
+                <a:solidFill>
+                  <a:srgbClr val="68717D"/>
+                </a:solidFill>
+                <a:latin typeface="DejaVu Sans"/>
+              </a:defRPr>
+            </a:pPr>
+            <a:r>
+              <a:t>Statistics through 30 September 2026 · values unchanged</a:t>
+            </a:r>
+          </a:p>
+        </p:txBody>
+      </p:sp>
+      <p:sp>
+        <p:nvSpPr>
+          <p:cNvPr id="14" name="TextBox 13"/>
+          <p:cNvSpPr txBox="1"/>
+          <p:nvPr/>
+        </p:nvSpPr>
+        <p:spPr>
+          <a:xfrm>
+            <a:off x="484632" y="1207008"/>
+            <a:ext cx="4023360" cy="274320"/>
           </a:xfrm>
           <a:prstGeom prst="rect">
             <a:avLst/>
@@ -12320,303 +12336,39 @@
               </a:defRPr>
             </a:pPr>
             <a:r>
-              <a:t>OCTOBER 2026 · PHOTOS &amp; RELEVANT HIGHLIGHTS · cut-off 27 Oct</a:t>
-            </a:r>
-          </a:p>
-        </p:txBody>
-      </p:sp>
-      <p:sp>
-        <p:nvSpPr>
-          <p:cNvPr id="14" name="Rectangle 13"/>
+              <a:t>TOTAL WASTE GENERATION (kg/month)</a:t>
+            </a:r>
+          </a:p>
+        </p:txBody>
+      </p:sp>
+      <p:graphicFrame>
+        <p:nvGraphicFramePr>
+          <p:cNvPr id="15" name="Chart 14"/>
+          <p:cNvGraphicFramePr>
+            <a:graphicFrameLocks noGrp="1"/>
+          </p:cNvGraphicFramePr>
+          <p:nvPr/>
+        </p:nvGraphicFramePr>
+        <p:xfrm>
+          <a:off x="457200" y="1572768"/>
+          <a:ext cx="3063240" cy="2121408"/>
+        </p:xfrm>
+        <a:graphic>
+          <a:graphicData uri="http://schemas.openxmlformats.org/drawingml/2006/chart">
+            <c:chart xmlns:c="http://schemas.openxmlformats.org/drawingml/2006/chart" xmlns:r="http://schemas.openxmlformats.org/officeDocument/2006/relationships" r:id="rId4"/>
+          </a:graphicData>
+        </a:graphic>
+      </p:graphicFrame>
+      <p:sp>
+        <p:nvSpPr>
+          <p:cNvPr id="16" name="Rectangle 15"/>
           <p:cNvSpPr/>
           <p:nvPr/>
         </p:nvSpPr>
         <p:spPr>
           <a:xfrm>
-            <a:off x="411480" y="1417320"/>
-            <a:ext cx="4023360" cy="2331720"/>
-          </a:xfrm>
-          <a:prstGeom prst="rect">
-            <a:avLst/>
-          </a:prstGeom>
-          <a:solidFill>
-            <a:srgbClr val="F2F3F5"/>
-          </a:solidFill>
-          <a:ln>
-            <a:solidFill>
-              <a:srgbClr val="CDD2D9"/>
-            </a:solidFill>
-          </a:ln>
-          <a:effectLst/>
-        </p:spPr>
-        <p:style>
-          <a:lnRef idx="1">
-            <a:schemeClr val="accent1"/>
-          </a:lnRef>
-          <a:fillRef idx="3">
-            <a:schemeClr val="accent1"/>
-          </a:fillRef>
-          <a:effectRef idx="2">
-            <a:schemeClr val="accent1"/>
-          </a:effectRef>
-          <a:fontRef idx="minor">
-            <a:schemeClr val="lt1"/>
-          </a:fontRef>
-        </p:style>
-        <p:txBody>
-          <a:bodyPr rtlCol="0" anchor="ctr"/>
-          <a:lstStyle/>
-          <a:p>
-            <a:pPr algn="ctr"/>
-            <a:endParaRPr/>
-          </a:p>
-        </p:txBody>
-      </p:sp>
-      <p:sp>
-        <p:nvSpPr>
-          <p:cNvPr id="15" name="TextBox 14"/>
-          <p:cNvSpPr txBox="1"/>
-          <p:nvPr/>
-        </p:nvSpPr>
-        <p:spPr>
-          <a:xfrm>
-            <a:off x="548640" y="2148840"/>
-            <a:ext cx="3749039" cy="640080"/>
-          </a:xfrm>
-          <a:prstGeom prst="rect">
-            <a:avLst/>
-          </a:prstGeom>
-          <a:noFill/>
-        </p:spPr>
-        <p:txBody>
-          <a:bodyPr wrap="square" lIns="18288" tIns="0" rIns="18288" bIns="0">
-            <a:spAutoFit/>
-          </a:bodyPr>
-          <a:lstStyle/>
-          <a:p>
-            <a:pPr algn="ctr">
-              <a:spcAft>
-                <a:spcPts val="500"/>
-              </a:spcAft>
-              <a:defRPr sz="1500" b="0">
-                <a:solidFill>
-                  <a:srgbClr val="68717D"/>
-                </a:solidFill>
-                <a:latin typeface="DejaVu Sans"/>
-              </a:defRPr>
-            </a:pPr>
-            <a:r>
-              <a:t>OCTOBER PHOTO 1</a:t>
-            </a:r>
-          </a:p>
-          <a:p>
-            <a:pPr algn="ctr">
-              <a:spcAft>
-                <a:spcPts val="500"/>
-              </a:spcAft>
-              <a:defRPr sz="1500" b="0">
-                <a:solidFill>
-                  <a:srgbClr val="68717D"/>
-                </a:solidFill>
-                <a:latin typeface="DejaVu Sans"/>
-              </a:defRPr>
-            </a:pPr>
-            <a:r>
-              <a:t>Pending actual photo</a:t>
-            </a:r>
-          </a:p>
-        </p:txBody>
-      </p:sp>
-      <p:sp>
-        <p:nvSpPr>
-          <p:cNvPr id="16" name="TextBox 15"/>
-          <p:cNvSpPr txBox="1"/>
-          <p:nvPr/>
-        </p:nvSpPr>
-        <p:spPr>
-          <a:xfrm>
-            <a:off x="411480" y="3867912"/>
-            <a:ext cx="4023360" cy="502920"/>
-          </a:xfrm>
-          <a:prstGeom prst="rect">
-            <a:avLst/>
-          </a:prstGeom>
-          <a:noFill/>
-        </p:spPr>
-        <p:txBody>
-          <a:bodyPr wrap="square" lIns="18288" tIns="0" rIns="18288" bIns="0">
-            <a:spAutoFit/>
-          </a:bodyPr>
-          <a:lstStyle/>
-          <a:p>
-            <a:pPr>
-              <a:spcAft>
-                <a:spcPts val="500"/>
-              </a:spcAft>
-              <a:defRPr sz="950" b="0">
-                <a:solidFill>
-                  <a:srgbClr val="68717D"/>
-                </a:solidFill>
-                <a:latin typeface="DejaVu Sans"/>
-              </a:defRPr>
-            </a:pPr>
-            <a:r>
-              <a:t>Date / location / activity: pending confirmation</a:t>
-            </a:r>
-          </a:p>
-        </p:txBody>
-      </p:sp>
-      <p:sp>
-        <p:nvSpPr>
-          <p:cNvPr id="17" name="Rectangle 16"/>
-          <p:cNvSpPr/>
-          <p:nvPr/>
-        </p:nvSpPr>
-        <p:spPr>
-          <a:xfrm>
-            <a:off x="4681728" y="1417320"/>
-            <a:ext cx="4023360" cy="2331720"/>
-          </a:xfrm>
-          <a:prstGeom prst="rect">
-            <a:avLst/>
-          </a:prstGeom>
-          <a:solidFill>
-            <a:srgbClr val="F2F3F5"/>
-          </a:solidFill>
-          <a:ln>
-            <a:solidFill>
-              <a:srgbClr val="CDD2D9"/>
-            </a:solidFill>
-          </a:ln>
-          <a:effectLst/>
-        </p:spPr>
-        <p:style>
-          <a:lnRef idx="1">
-            <a:schemeClr val="accent1"/>
-          </a:lnRef>
-          <a:fillRef idx="3">
-            <a:schemeClr val="accent1"/>
-          </a:fillRef>
-          <a:effectRef idx="2">
-            <a:schemeClr val="accent1"/>
-          </a:effectRef>
-          <a:fontRef idx="minor">
-            <a:schemeClr val="lt1"/>
-          </a:fontRef>
-        </p:style>
-        <p:txBody>
-          <a:bodyPr rtlCol="0" anchor="ctr"/>
-          <a:lstStyle/>
-          <a:p>
-            <a:pPr algn="ctr"/>
-            <a:endParaRPr/>
-          </a:p>
-        </p:txBody>
-      </p:sp>
-      <p:sp>
-        <p:nvSpPr>
-          <p:cNvPr id="18" name="TextBox 17"/>
-          <p:cNvSpPr txBox="1"/>
-          <p:nvPr/>
-        </p:nvSpPr>
-        <p:spPr>
-          <a:xfrm>
-            <a:off x="4818888" y="2148840"/>
-            <a:ext cx="3749039" cy="640080"/>
-          </a:xfrm>
-          <a:prstGeom prst="rect">
-            <a:avLst/>
-          </a:prstGeom>
-          <a:noFill/>
-        </p:spPr>
-        <p:txBody>
-          <a:bodyPr wrap="square" lIns="18288" tIns="0" rIns="18288" bIns="0">
-            <a:spAutoFit/>
-          </a:bodyPr>
-          <a:lstStyle/>
-          <a:p>
-            <a:pPr algn="ctr">
-              <a:spcAft>
-                <a:spcPts val="500"/>
-              </a:spcAft>
-              <a:defRPr sz="1500" b="0">
-                <a:solidFill>
-                  <a:srgbClr val="68717D"/>
-                </a:solidFill>
-                <a:latin typeface="DejaVu Sans"/>
-              </a:defRPr>
-            </a:pPr>
-            <a:r>
-              <a:t>OCTOBER PHOTO 2</a:t>
-            </a:r>
-          </a:p>
-          <a:p>
-            <a:pPr algn="ctr">
-              <a:spcAft>
-                <a:spcPts val="500"/>
-              </a:spcAft>
-              <a:defRPr sz="1500" b="0">
-                <a:solidFill>
-                  <a:srgbClr val="68717D"/>
-                </a:solidFill>
-                <a:latin typeface="DejaVu Sans"/>
-              </a:defRPr>
-            </a:pPr>
-            <a:r>
-              <a:t>Pending actual photo</a:t>
-            </a:r>
-          </a:p>
-        </p:txBody>
-      </p:sp>
-      <p:sp>
-        <p:nvSpPr>
-          <p:cNvPr id="19" name="TextBox 18"/>
-          <p:cNvSpPr txBox="1"/>
-          <p:nvPr/>
-        </p:nvSpPr>
-        <p:spPr>
-          <a:xfrm>
-            <a:off x="4681728" y="3867912"/>
-            <a:ext cx="4023360" cy="502920"/>
-          </a:xfrm>
-          <a:prstGeom prst="rect">
-            <a:avLst/>
-          </a:prstGeom>
-          <a:noFill/>
-        </p:spPr>
-        <p:txBody>
-          <a:bodyPr wrap="square" lIns="18288" tIns="0" rIns="18288" bIns="0">
-            <a:spAutoFit/>
-          </a:bodyPr>
-          <a:lstStyle/>
-          <a:p>
-            <a:pPr>
-              <a:spcAft>
-                <a:spcPts val="500"/>
-              </a:spcAft>
-              <a:defRPr sz="950" b="0">
-                <a:solidFill>
-                  <a:srgbClr val="68717D"/>
-                </a:solidFill>
-                <a:latin typeface="DejaVu Sans"/>
-              </a:defRPr>
-            </a:pPr>
-            <a:r>
-              <a:t>Date / location / activity: pending confirmation</a:t>
-            </a:r>
-          </a:p>
-        </p:txBody>
-      </p:sp>
-      <p:sp>
-        <p:nvSpPr>
-          <p:cNvPr id="20" name="Rectangle 19"/>
-          <p:cNvSpPr/>
-          <p:nvPr/>
-        </p:nvSpPr>
-        <p:spPr>
-          <a:xfrm>
-            <a:off x="411480" y="4590288"/>
-            <a:ext cx="8293608" cy="1554480"/>
+            <a:off x="4114800" y="1901952"/>
+            <a:ext cx="2240280" cy="1024128"/>
           </a:xfrm>
           <a:prstGeom prst="rect">
             <a:avLst/>
@@ -12654,14 +12406,59 @@
       </p:sp>
       <p:sp>
         <p:nvSpPr>
-          <p:cNvPr id="21" name="TextBox 20"/>
+          <p:cNvPr id="17" name="Rectangle 16"/>
+          <p:cNvSpPr/>
+          <p:nvPr/>
+        </p:nvSpPr>
+        <p:spPr>
+          <a:xfrm>
+            <a:off x="4114800" y="1901952"/>
+            <a:ext cx="50292" cy="1024128"/>
+          </a:xfrm>
+          <a:prstGeom prst="rect">
+            <a:avLst/>
+          </a:prstGeom>
+          <a:solidFill>
+            <a:srgbClr val="013EF5"/>
+          </a:solidFill>
+          <a:ln>
+            <a:noFill/>
+          </a:ln>
+          <a:effectLst/>
+        </p:spPr>
+        <p:style>
+          <a:lnRef idx="1">
+            <a:schemeClr val="accent1"/>
+          </a:lnRef>
+          <a:fillRef idx="3">
+            <a:schemeClr val="accent1"/>
+          </a:fillRef>
+          <a:effectRef idx="2">
+            <a:schemeClr val="accent1"/>
+          </a:effectRef>
+          <a:fontRef idx="minor">
+            <a:schemeClr val="lt1"/>
+          </a:fontRef>
+        </p:style>
+        <p:txBody>
+          <a:bodyPr rtlCol="0" anchor="ctr"/>
+          <a:lstStyle/>
+          <a:p>
+            <a:pPr algn="ctr"/>
+            <a:endParaRPr/>
+          </a:p>
+        </p:txBody>
+      </p:sp>
+      <p:sp>
+        <p:nvSpPr>
+          <p:cNvPr id="18" name="TextBox 17"/>
           <p:cNvSpPr txBox="1"/>
           <p:nvPr/>
         </p:nvSpPr>
         <p:spPr>
           <a:xfrm>
-            <a:off x="566928" y="4727448"/>
-            <a:ext cx="8001000" cy="274320"/>
+            <a:off x="4224528" y="1984248"/>
+            <a:ext cx="2057400" cy="320040"/>
           </a:xfrm>
           <a:prstGeom prst="rect">
             <a:avLst/>
@@ -12678,7 +12475,46 @@
               <a:spcAft>
                 <a:spcPts val="500"/>
               </a:spcAft>
-              <a:defRPr sz="1200" b="1">
+              <a:defRPr sz="850" b="1">
+                <a:solidFill>
+                  <a:srgbClr val="68717D"/>
+                </a:solidFill>
+                <a:latin typeface="DejaVu Sans"/>
+              </a:defRPr>
+            </a:pPr>
+            <a:r>
+              <a:t>% Waste recovery</a:t>
+            </a:r>
+          </a:p>
+        </p:txBody>
+      </p:sp>
+      <p:sp>
+        <p:nvSpPr>
+          <p:cNvPr id="19" name="TextBox 18"/>
+          <p:cNvSpPr txBox="1"/>
+          <p:nvPr/>
+        </p:nvSpPr>
+        <p:spPr>
+          <a:xfrm>
+            <a:off x="4224528" y="2359152"/>
+            <a:ext cx="2011680" cy="475488"/>
+          </a:xfrm>
+          <a:prstGeom prst="rect">
+            <a:avLst/>
+          </a:prstGeom>
+          <a:noFill/>
+        </p:spPr>
+        <p:txBody>
+          <a:bodyPr wrap="square" lIns="18288" tIns="0" rIns="18288" bIns="0">
+            <a:spAutoFit/>
+          </a:bodyPr>
+          <a:lstStyle/>
+          <a:p>
+            <a:pPr>
+              <a:spcAft>
+                <a:spcPts val="500"/>
+              </a:spcAft>
+              <a:defRPr sz="2800" b="1">
                 <a:solidFill>
                   <a:srgbClr val="013EF5"/>
                 </a:solidFill>
@@ -12686,8 +12522,98 @@
               </a:defRPr>
             </a:pPr>
             <a:r>
-              <a:t>SAFETY — RELEVANT OCTOBER TOPICS</a:t>
-            </a:r>
+              <a:t>0%</a:t>
+            </a:r>
+          </a:p>
+        </p:txBody>
+      </p:sp>
+      <p:sp>
+        <p:nvSpPr>
+          <p:cNvPr id="20" name="Rectangle 19"/>
+          <p:cNvSpPr/>
+          <p:nvPr/>
+        </p:nvSpPr>
+        <p:spPr>
+          <a:xfrm>
+            <a:off x="6446520" y="1901952"/>
+            <a:ext cx="2240280" cy="1024128"/>
+          </a:xfrm>
+          <a:prstGeom prst="rect">
+            <a:avLst/>
+          </a:prstGeom>
+          <a:solidFill>
+            <a:srgbClr val="F2F3F5"/>
+          </a:solidFill>
+          <a:ln>
+            <a:noFill/>
+          </a:ln>
+          <a:effectLst/>
+        </p:spPr>
+        <p:style>
+          <a:lnRef idx="1">
+            <a:schemeClr val="accent1"/>
+          </a:lnRef>
+          <a:fillRef idx="3">
+            <a:schemeClr val="accent1"/>
+          </a:fillRef>
+          <a:effectRef idx="2">
+            <a:schemeClr val="accent1"/>
+          </a:effectRef>
+          <a:fontRef idx="minor">
+            <a:schemeClr val="lt1"/>
+          </a:fontRef>
+        </p:style>
+        <p:txBody>
+          <a:bodyPr rtlCol="0" anchor="ctr"/>
+          <a:lstStyle/>
+          <a:p>
+            <a:pPr algn="ctr"/>
+            <a:endParaRPr/>
+          </a:p>
+        </p:txBody>
+      </p:sp>
+      <p:sp>
+        <p:nvSpPr>
+          <p:cNvPr id="21" name="Rectangle 20"/>
+          <p:cNvSpPr/>
+          <p:nvPr/>
+        </p:nvSpPr>
+        <p:spPr>
+          <a:xfrm>
+            <a:off x="6446520" y="1901952"/>
+            <a:ext cx="50292" cy="1024128"/>
+          </a:xfrm>
+          <a:prstGeom prst="rect">
+            <a:avLst/>
+          </a:prstGeom>
+          <a:solidFill>
+            <a:srgbClr val="013EF5"/>
+          </a:solidFill>
+          <a:ln>
+            <a:noFill/>
+          </a:ln>
+          <a:effectLst/>
+        </p:spPr>
+        <p:style>
+          <a:lnRef idx="1">
+            <a:schemeClr val="accent1"/>
+          </a:lnRef>
+          <a:fillRef idx="3">
+            <a:schemeClr val="accent1"/>
+          </a:fillRef>
+          <a:effectRef idx="2">
+            <a:schemeClr val="accent1"/>
+          </a:effectRef>
+          <a:fontRef idx="minor">
+            <a:schemeClr val="lt1"/>
+          </a:fontRef>
+        </p:style>
+        <p:txBody>
+          <a:bodyPr rtlCol="0" anchor="ctr"/>
+          <a:lstStyle/>
+          <a:p>
+            <a:pPr algn="ctr"/>
+            <a:endParaRPr/>
           </a:p>
         </p:txBody>
       </p:sp>
@@ -12699,8 +12625,8 @@
         </p:nvSpPr>
         <p:spPr>
           <a:xfrm>
-            <a:off x="566928" y="5184648"/>
-            <a:ext cx="7863840" cy="749808"/>
+            <a:off x="6556248" y="1984248"/>
+            <a:ext cx="2057400" cy="320040"/>
           </a:xfrm>
           <a:prstGeom prst="rect">
             <a:avLst/>
@@ -12717,38 +12643,118 @@
               <a:spcAft>
                 <a:spcPts val="500"/>
               </a:spcAft>
-              <a:defRPr sz="1200" b="0">
+              <a:defRPr sz="850" b="1">
                 <a:solidFill>
-                  <a:srgbClr val="27364A"/>
+                  <a:srgbClr val="68717D"/>
                 </a:solidFill>
                 <a:latin typeface="DejaVu Sans"/>
               </a:defRPr>
             </a:pPr>
             <a:r>
-              <a:t>[Pending topics from Leandro Doglio]</a:t>
-            </a:r>
-          </a:p>
+              <a:t>% Waste final disposal / incinerated</a:t>
+            </a:r>
+          </a:p>
+        </p:txBody>
+      </p:sp>
+      <p:sp>
+        <p:nvSpPr>
+          <p:cNvPr id="23" name="TextBox 22"/>
+          <p:cNvSpPr txBox="1"/>
+          <p:nvPr/>
+        </p:nvSpPr>
+        <p:spPr>
+          <a:xfrm>
+            <a:off x="6556248" y="2359152"/>
+            <a:ext cx="2011680" cy="475488"/>
+          </a:xfrm>
+          <a:prstGeom prst="rect">
+            <a:avLst/>
+          </a:prstGeom>
+          <a:noFill/>
+        </p:spPr>
+        <p:txBody>
+          <a:bodyPr wrap="square" lIns="18288" tIns="0" rIns="18288" bIns="0">
+            <a:spAutoFit/>
+          </a:bodyPr>
+          <a:lstStyle/>
           <a:p>
             <a:pPr>
               <a:spcAft>
                 <a:spcPts val="500"/>
               </a:spcAft>
-              <a:defRPr sz="1200" b="0">
+              <a:defRPr sz="2800" b="1">
                 <a:solidFill>
-                  <a:srgbClr val="27364A"/>
+                  <a:srgbClr val="013EF5"/>
                 </a:solidFill>
                 <a:latin typeface="DejaVu Sans"/>
               </a:defRPr>
             </a:pPr>
             <a:r>
-              <a:t>Confirmed development · relevance · next step</a:t>
-            </a:r>
-          </a:p>
-        </p:txBody>
-      </p:sp>
-      <p:sp>
-        <p:nvSpPr>
-          <p:cNvPr id="23" name="TextBox 22"/>
+              <a:t>100%</a:t>
+            </a:r>
+          </a:p>
+        </p:txBody>
+      </p:sp>
+      <p:sp>
+        <p:nvSpPr>
+          <p:cNvPr id="24" name="TextBox 23"/>
+          <p:cNvSpPr txBox="1"/>
+          <p:nvPr/>
+        </p:nvSpPr>
+        <p:spPr>
+          <a:xfrm>
+            <a:off x="484632" y="4023360"/>
+            <a:ext cx="4846320" cy="274320"/>
+          </a:xfrm>
+          <a:prstGeom prst="rect">
+            <a:avLst/>
+          </a:prstGeom>
+          <a:noFill/>
+        </p:spPr>
+        <p:txBody>
+          <a:bodyPr wrap="square" lIns="18288" tIns="0" rIns="18288" bIns="0">
+            <a:spAutoFit/>
+          </a:bodyPr>
+          <a:lstStyle/>
+          <a:p>
+            <a:pPr>
+              <a:spcAft>
+                <a:spcPts val="500"/>
+              </a:spcAft>
+              <a:defRPr sz="1100" b="1">
+                <a:solidFill>
+                  <a:srgbClr val="013EF5"/>
+                </a:solidFill>
+                <a:latin typeface="DejaVu Sans"/>
+              </a:defRPr>
+            </a:pPr>
+            <a:r>
+              <a:t>FRESHWATER CONSUMPTION (m³/month)</a:t>
+            </a:r>
+          </a:p>
+        </p:txBody>
+      </p:sp>
+      <p:graphicFrame>
+        <p:nvGraphicFramePr>
+          <p:cNvPr id="25" name="Chart 24"/>
+          <p:cNvGraphicFramePr>
+            <a:graphicFrameLocks noGrp="1"/>
+          </p:cNvGraphicFramePr>
+          <p:nvPr/>
+        </p:nvGraphicFramePr>
+        <p:xfrm>
+          <a:off x="457200" y="4370832"/>
+          <a:ext cx="3063240" cy="1947672"/>
+        </p:xfrm>
+        <a:graphic>
+          <a:graphicData uri="http://schemas.openxmlformats.org/drawingml/2006/chart">
+            <c:chart xmlns:c="http://schemas.openxmlformats.org/drawingml/2006/chart" xmlns:r="http://schemas.openxmlformats.org/officeDocument/2006/relationships" r:id="rId5"/>
+          </a:graphicData>
+        </a:graphic>
+      </p:graphicFrame>
+      <p:sp>
+        <p:nvSpPr>
+          <p:cNvPr id="26" name="TextBox 25"/>
           <p:cNvSpPr txBox="1"/>
           <p:nvPr/>
         </p:nvSpPr>
@@ -12787,7 +12793,7 @@
       </p:sp>
       <p:sp>
         <p:nvSpPr>
-          <p:cNvPr id="24" name="TextBox 23"/>
+          <p:cNvPr id="27" name="TextBox 26"/>
           <p:cNvSpPr txBox="1"/>
           <p:nvPr/>
         </p:nvSpPr>
@@ -12819,7 +12825,7 @@
               </a:defRPr>
             </a:pPr>
             <a:r>
-              <a:t>5</a:t>
+              <a:t>6</a:t>
             </a:r>
           </a:p>
         </p:txBody>
@@ -13159,8 +13165,8 @@
         </p:nvSpPr>
         <p:spPr>
           <a:xfrm>
-            <a:off x="603504" y="2185416"/>
-            <a:ext cx="7909560" cy="1024128"/>
+            <a:off x="603504" y="2103120"/>
+            <a:ext cx="7909560" cy="1207008"/>
           </a:xfrm>
           <a:prstGeom prst="rect">
             <a:avLst/>
@@ -13175,7 +13181,7 @@
           <a:p>
             <a:pPr>
               <a:spcAft>
-                <a:spcPts val="800"/>
+                <a:spcPts val="400"/>
               </a:spcAft>
               <a:defRPr sz="1230" b="0">
                 <a:solidFill>
@@ -13185,13 +13191,15 @@
               </a:defRPr>
             </a:pPr>
             <a:r>
-              <a:t>“Allen Compressor Plant Update” addendum approved on 21 October 2026 (Resolution 962/2026).</a:t>
+              <a:rPr sz="1200"/>
+              <a:t>“Allen Compressor Plant Update” addendum approved on 21 October 2026 (Resolution 962/2026).
+The decision on the cold vent stack (“Stack Frío”) remains pending. SMP must submit a comparative analysis of flaring and cold venting to the competent authority for discussion.</a:t>
             </a:r>
           </a:p>
           <a:p>
             <a:pPr>
               <a:spcAft>
-                <a:spcPts val="800"/>
+                <a:spcPts val="400"/>
               </a:spcAft>
               <a:defRPr sz="1230" b="0">
                 <a:solidFill>
@@ -13200,9 +13208,6 @@
                 <a:latin typeface="DejaVu Sans"/>
               </a:defRPr>
             </a:pPr>
-            <a:r>
-              <a:t>Open item: SMP to submit a flaring vs cold-venting comparison for discussion with the environmental authority.</a:t>
-            </a:r>
           </a:p>
         </p:txBody>
       </p:sp>
@@ -13313,7 +13318,7 @@
           <a:p>
             <a:pPr>
               <a:spcAft>
-                <a:spcPts val="800"/>
+                <a:spcPts val="400"/>
               </a:spcAft>
               <a:defRPr sz="1230" b="0">
                 <a:solidFill>
@@ -13323,13 +13328,15 @@
               </a:defRPr>
             </a:pPr>
             <a:r>
-              <a:t>Pending action with Serman: address comments on the Water Risk Study and submit the response to SSRH.</a:t>
+              <a:rPr sz="1200"/>
+              <a:t>The response to comments on the Water Risk Study and its submission to SSRH remain pending, in coordination with Serman.
+Purpose: advance the water permit application for the Neuquén section.</a:t>
             </a:r>
           </a:p>
           <a:p>
             <a:pPr>
               <a:spcAft>
-                <a:spcPts val="800"/>
+                <a:spcPts val="400"/>
               </a:spcAft>
               <a:defRPr sz="1230" b="0">
                 <a:solidFill>
@@ -13338,9 +13345,6 @@
                 <a:latin typeface="DejaVu Sans"/>
               </a:defRPr>
             </a:pPr>
-            <a:r>
-              <a:t>Purpose: obtain the water permit for the Neuquén section.</a:t>
-            </a:r>
           </a:p>
         </p:txBody>
       </p:sp>

</xml_diff>